<commit_message>
P10.11: references return in two columns; near-shore block retires
The "Near shore, every detector fails" block repeated numbers shown
elsewhere (0.4% vs 31% and recall <= 0.021 in finding 4 and the recall
chart; machine-made labels in the Data bullet and Limits). Its slot in
column 3 now holds the references as two columns of five, lifted 14 mm
like the recall block, with hyphenation off. The one number found nowhere
else, the best cell's verified F1 offshore vs within 2 km (0.724 vs
0.026), moves into the detection-crop caption. The 34-of-4,302
prediction count and the precision range stay in the report.

references.tex/.pdf remains as a printable copy with full titles and page
ranges. The PowerPoint mirrors the change; check_poster.py passes (17
numbers match) and the pptx validator passes.
</commit_message>
<xml_diff>
--- a/docs/poster/poster.pptx
+++ b/docs/poster/poster.pptx
@@ -4083,7 +4083,7 @@
         <p:spPr>
           <a:xfrm>
             <a:off x="1042416" y="30596786"/>
-            <a:ext cx="8293608" cy="731520"/>
+            <a:ext cx="8293608" cy="1097280"/>
           </a:xfrm>
           <a:prstGeom prst="rect">
             <a:avLst/>
@@ -4108,7 +4108,7 @@
                 </a:solidFill>
                 <a:latin typeface="Arial"/>
               </a:rPr>
-              <a:t>Best cell (ImageNet CNN, 111 scenes) on two 8 × 8 km verified crops (VH, dB): offshore it finds almost every vessel; in this harbor, none.</a:t>
+              <a:t>Best cell (ImageNet CNN, 111 scenes) on two 8 × 8 km verified crops (VH, dB): offshore it finds almost every vessel; in this harbor, none. Its verified F1 is 0.724 offshore and 0.026 within 2 km of shore.</a:t>
             </a:r>
           </a:p>
         </p:txBody>
@@ -5941,13 +5941,13 @@
       </p:sp>
       <p:sp>
         <p:nvSpPr>
-          <p:cNvPr id="57" name="heading: Near shore, every detector fails"/>
+          <p:cNvPr id="57" name="heading: References"/>
           <p:cNvSpPr txBox="1"/>
           <p:nvPr/>
         </p:nvSpPr>
         <p:spPr>
           <a:xfrm>
-            <a:off x="19687032" y="27669744"/>
+            <a:off x="19687032" y="27038808"/>
             <a:ext cx="13962888" cy="685800"/>
           </a:xfrm>
           <a:prstGeom prst="rect">
@@ -5973,20 +5973,20 @@
                 </a:solidFill>
                 <a:latin typeface="Arial"/>
               </a:rPr>
-              <a:t>Near shore, every detector fails</a:t>
+              <a:t>References</a:t>
             </a:r>
           </a:p>
         </p:txBody>
       </p:sp>
       <p:cxnSp>
         <p:nvCxnSpPr>
-          <p:cNvPr id="58" name="rule: Near shore, every detector fails"/>
+          <p:cNvPr id="58" name="rule: References"/>
           <p:cNvCxnSpPr/>
           <p:nvPr/>
         </p:nvCxnSpPr>
         <p:spPr>
           <a:xfrm>
-            <a:off x="19687032" y="28446984"/>
+            <a:off x="19687032" y="27816048"/>
             <a:ext cx="13962888" cy="0"/>
           </a:xfrm>
           <a:prstGeom prst="line">
@@ -6015,14 +6015,14 @@
       </p:cxnSp>
       <p:sp>
         <p:nvSpPr>
-          <p:cNvPr id="59" name="stat 1 value"/>
+          <p:cNvPr id="59" name="references 1"/>
           <p:cNvSpPr txBox="1"/>
           <p:nvPr/>
         </p:nvSpPr>
         <p:spPr>
           <a:xfrm>
-            <a:off x="19943064" y="28629864"/>
-            <a:ext cx="4483608" cy="822960"/>
+            <a:off x="19943064" y="28090368"/>
+            <a:ext cx="6588251" cy="3547871"/>
           </a:xfrm>
           <a:prstGeom prst="rect">
             <a:avLst/>
@@ -6031,6 +6031,302 @@
         </p:spPr>
         <p:txBody>
           <a:bodyPr wrap="square" anchor="t" lIns="0" rIns="0" tIns="0" bIns="0">
+            <a:spAutoFit/>
+          </a:bodyPr>
+          <a:lstStyle/>
+          <a:p>
+            <a:pPr algn="l">
+              <a:spcAft>
+                <a:spcPts val="400"/>
+              </a:spcAft>
+            </a:pPr>
+            <a:r>
+              <a:rPr sz="1700" b="0" i="0">
+                <a:solidFill>
+                  <a:srgbClr val="5B6477"/>
+                </a:solidFill>
+                <a:latin typeface="Arial"/>
+              </a:rPr>
+              <a:t>[1]  </a:t>
+            </a:r>
+            <a:r>
+              <a:rPr sz="1700" b="0" i="0">
+                <a:solidFill>
+                  <a:srgbClr val="1F2328"/>
+                </a:solidFill>
+                <a:latin typeface="Arial"/>
+              </a:rPr>
+              <a:t>F. S. Paolo et al. xView3-SAR: Detecting dark fishing activity using SAR imagery. NeurIPS 2022.</a:t>
+            </a:r>
+          </a:p>
+          <a:p>
+            <a:pPr algn="l">
+              <a:spcAft>
+                <a:spcPts val="400"/>
+              </a:spcAft>
+            </a:pPr>
+            <a:r>
+              <a:rPr sz="1700" b="0" i="0">
+                <a:solidFill>
+                  <a:srgbClr val="5B6477"/>
+                </a:solidFill>
+                <a:latin typeface="Arial"/>
+              </a:rPr>
+              <a:t>[2]  </a:t>
+            </a:r>
+            <a:r>
+              <a:rPr sz="1700" b="0" i="0">
+                <a:solidFill>
+                  <a:srgbClr val="1F2328"/>
+                </a:solidFill>
+                <a:latin typeface="Arial"/>
+              </a:rPr>
+              <a:t>R. Torres et al. GMES Sentinel-1 mission. Remote Sens. Environ. 2012.</a:t>
+            </a:r>
+          </a:p>
+          <a:p>
+            <a:pPr algn="l">
+              <a:spcAft>
+                <a:spcPts val="400"/>
+              </a:spcAft>
+            </a:pPr>
+            <a:r>
+              <a:rPr sz="1700" b="0" i="0">
+                <a:solidFill>
+                  <a:srgbClr val="5B6477"/>
+                </a:solidFill>
+                <a:latin typeface="Arial"/>
+              </a:rPr>
+              <a:t>[3]  </a:t>
+            </a:r>
+            <a:r>
+              <a:rPr sz="1700" b="0" i="0">
+                <a:solidFill>
+                  <a:srgbClr val="1F2328"/>
+                </a:solidFill>
+                <a:latin typeface="Arial"/>
+              </a:rPr>
+              <a:t>A. Dosovitskiy et al. An image is worth 16×16 words. ICLR 2021.</a:t>
+            </a:r>
+          </a:p>
+          <a:p>
+            <a:pPr algn="l">
+              <a:spcAft>
+                <a:spcPts val="400"/>
+              </a:spcAft>
+            </a:pPr>
+            <a:r>
+              <a:rPr sz="1700" b="0" i="0">
+                <a:solidFill>
+                  <a:srgbClr val="5B6477"/>
+                </a:solidFill>
+                <a:latin typeface="Arial"/>
+              </a:rPr>
+              <a:t>[4]  </a:t>
+            </a:r>
+            <a:r>
+              <a:rPr sz="1700" b="0" i="0">
+                <a:solidFill>
+                  <a:srgbClr val="1F2328"/>
+                </a:solidFill>
+                <a:latin typeface="Arial"/>
+              </a:rPr>
+              <a:t>S. Woo et al. ConvNeXt V2: Co-designing and scaling ConvNets with masked autoencoders. CVPR 2023.</a:t>
+            </a:r>
+          </a:p>
+          <a:p>
+            <a:pPr algn="l">
+              <a:spcAft>
+                <a:spcPts val="400"/>
+              </a:spcAft>
+            </a:pPr>
+            <a:r>
+              <a:rPr sz="1700" b="0" i="0">
+                <a:solidFill>
+                  <a:srgbClr val="5B6477"/>
+                </a:solidFill>
+                <a:latin typeface="Arial"/>
+              </a:rPr>
+              <a:t>[5]  </a:t>
+            </a:r>
+            <a:r>
+              <a:rPr sz="1700" b="0" i="0">
+                <a:solidFill>
+                  <a:srgbClr val="1F2328"/>
+                </a:solidFill>
+                <a:latin typeface="Arial"/>
+              </a:rPr>
+              <a:t>A. Steiner et al. How to train your ViT? TMLR 2022.</a:t>
+            </a:r>
+          </a:p>
+        </p:txBody>
+      </p:sp>
+      <p:sp>
+        <p:nvSpPr>
+          <p:cNvPr id="60" name="references 2"/>
+          <p:cNvSpPr txBox="1"/>
+          <p:nvPr/>
+        </p:nvSpPr>
+        <p:spPr>
+          <a:xfrm>
+            <a:off x="26805636" y="28090368"/>
+            <a:ext cx="6588251" cy="3547871"/>
+          </a:xfrm>
+          <a:prstGeom prst="rect">
+            <a:avLst/>
+          </a:prstGeom>
+          <a:noFill/>
+        </p:spPr>
+        <p:txBody>
+          <a:bodyPr wrap="square" anchor="t" lIns="0" rIns="0" tIns="0" bIns="0">
+            <a:spAutoFit/>
+          </a:bodyPr>
+          <a:lstStyle/>
+          <a:p>
+            <a:pPr algn="l">
+              <a:spcAft>
+                <a:spcPts val="400"/>
+              </a:spcAft>
+            </a:pPr>
+            <a:r>
+              <a:rPr sz="1700" b="0" i="0">
+                <a:solidFill>
+                  <a:srgbClr val="5B6477"/>
+                </a:solidFill>
+                <a:latin typeface="Arial"/>
+              </a:rPr>
+              <a:t>[6]  </a:t>
+            </a:r>
+            <a:r>
+              <a:rPr sz="1700" b="0" i="0">
+                <a:solidFill>
+                  <a:srgbClr val="1F2328"/>
+                </a:solidFill>
+                <a:latin typeface="Arial"/>
+              </a:rPr>
+              <a:t>J. Straka and I. Gruber. SatDINO: A deep dive into self-supervised pretraining for remote sensing. arXiv:2508.21402, 2025.</a:t>
+            </a:r>
+          </a:p>
+          <a:p>
+            <a:pPr algn="l">
+              <a:spcAft>
+                <a:spcPts val="400"/>
+              </a:spcAft>
+            </a:pPr>
+            <a:r>
+              <a:rPr sz="1700" b="0" i="0">
+                <a:solidFill>
+                  <a:srgbClr val="5B6477"/>
+                </a:solidFill>
+                <a:latin typeface="Arial"/>
+              </a:rPr>
+              <a:t>[7]  </a:t>
+            </a:r>
+            <a:r>
+              <a:rPr sz="1700" b="0" i="0">
+                <a:solidFill>
+                  <a:srgbClr val="1F2328"/>
+                </a:solidFill>
+                <a:latin typeface="Arial"/>
+              </a:rPr>
+              <a:t>D. Liu et al. SARMAE: Masked autoencoder for SAR representation learning. CVPR 2026.</a:t>
+            </a:r>
+          </a:p>
+          <a:p>
+            <a:pPr algn="l">
+              <a:spcAft>
+                <a:spcPts val="400"/>
+              </a:spcAft>
+            </a:pPr>
+            <a:r>
+              <a:rPr sz="1700" b="0" i="0">
+                <a:solidFill>
+                  <a:srgbClr val="5B6477"/>
+                </a:solidFill>
+                <a:latin typeface="Arial"/>
+              </a:rPr>
+              <a:t>[8]  </a:t>
+            </a:r>
+            <a:r>
+              <a:rPr sz="1700" b="0" i="0">
+                <a:solidFill>
+                  <a:srgbClr val="1F2328"/>
+                </a:solidFill>
+                <a:latin typeface="Arial"/>
+              </a:rPr>
+              <a:t>K. N. Clasen et al. reBEN: Refined BigEarthNet dataset. IGARSS 2025.</a:t>
+            </a:r>
+          </a:p>
+          <a:p>
+            <a:pPr algn="l">
+              <a:spcAft>
+                <a:spcPts val="400"/>
+              </a:spcAft>
+            </a:pPr>
+            <a:r>
+              <a:rPr sz="1700" b="0" i="0">
+                <a:solidFill>
+                  <a:srgbClr val="5B6477"/>
+                </a:solidFill>
+                <a:latin typeface="Arial"/>
+              </a:rPr>
+              <a:t>[9]  </a:t>
+            </a:r>
+            <a:r>
+              <a:rPr sz="1700" b="0" i="0">
+                <a:solidFill>
+                  <a:srgbClr val="1F2328"/>
+                </a:solidFill>
+                <a:latin typeface="Arial"/>
+              </a:rPr>
+              <a:t>X. Zhou, D. Wang, and P. Krähenbühl. Objects as points. arXiv:1904.07850, 2019.</a:t>
+            </a:r>
+          </a:p>
+          <a:p>
+            <a:pPr algn="l">
+              <a:spcAft>
+                <a:spcPts val="400"/>
+              </a:spcAft>
+            </a:pPr>
+            <a:r>
+              <a:rPr sz="1700" b="0" i="0">
+                <a:solidFill>
+                  <a:srgbClr val="5B6477"/>
+                </a:solidFill>
+                <a:latin typeface="Arial"/>
+              </a:rPr>
+              <a:t>[10]  </a:t>
+            </a:r>
+            <a:r>
+              <a:rPr sz="1700" b="0" i="0">
+                <a:solidFill>
+                  <a:srgbClr val="1F2328"/>
+                </a:solidFill>
+                <a:latin typeface="Arial"/>
+              </a:rPr>
+              <a:t>T.-Y. Lin et al. Focal loss for dense object detection. ICCV 2017.</a:t>
+            </a:r>
+          </a:p>
+        </p:txBody>
+      </p:sp>
+      <p:sp>
+        <p:nvSpPr>
+          <p:cNvPr id="61" name="heading: Findings"/>
+          <p:cNvSpPr txBox="1"/>
+          <p:nvPr/>
+        </p:nvSpPr>
+        <p:spPr>
+          <a:xfrm>
+            <a:off x="34299144" y="6702552"/>
+            <a:ext cx="8805672" cy="685800"/>
+          </a:xfrm>
+          <a:prstGeom prst="rect">
+            <a:avLst/>
+          </a:prstGeom>
+          <a:noFill/>
+        </p:spPr>
+        <p:txBody>
+          <a:bodyPr wrap="square" anchor="b" lIns="0" rIns="0" tIns="0" bIns="0">
             <a:spAutoFit/>
           </a:bodyPr>
           <a:lstStyle/>
@@ -6041,327 +6337,6 @@
               </a:spcAft>
             </a:pPr>
             <a:r>
-              <a:rPr sz="5200" b="1" i="0">
-                <a:solidFill>
-                  <a:srgbClr val="14213D"/>
-                </a:solidFill>
-                <a:latin typeface="Arial"/>
-              </a:rPr>
-              <a:t>0.026 vs 0.724</a:t>
-            </a:r>
-          </a:p>
-        </p:txBody>
-      </p:sp>
-      <p:sp>
-        <p:nvSpPr>
-          <p:cNvPr id="60" name="stat 1 label"/>
-          <p:cNvSpPr txBox="1"/>
-          <p:nvPr/>
-        </p:nvSpPr>
-        <p:spPr>
-          <a:xfrm>
-            <a:off x="19943064" y="29498544"/>
-            <a:ext cx="4483608" cy="777240"/>
-          </a:xfrm>
-          <a:prstGeom prst="rect">
-            <a:avLst/>
-          </a:prstGeom>
-          <a:noFill/>
-        </p:spPr>
-        <p:txBody>
-          <a:bodyPr wrap="square" anchor="t" lIns="0" rIns="0" tIns="0" bIns="0">
-            <a:spAutoFit/>
-          </a:bodyPr>
-          <a:lstStyle/>
-          <a:p>
-            <a:pPr algn="ctr">
-              <a:spcAft>
-                <a:spcPts val="0"/>
-              </a:spcAft>
-            </a:pPr>
-            <a:r>
-              <a:rPr sz="2000" b="0" i="0">
-                <a:solidFill>
-                  <a:srgbClr val="1F2328"/>
-                </a:solidFill>
-                <a:latin typeface="Arial"/>
-              </a:rPr>
-              <a:t>best cell's verified F1:</a:t>
-            </a:r>
-          </a:p>
-          <a:p>
-            <a:pPr algn="ctr">
-              <a:spcAft>
-                <a:spcPts val="0"/>
-              </a:spcAft>
-            </a:pPr>
-            <a:r>
-              <a:rPr sz="2000" b="0" i="0">
-                <a:solidFill>
-                  <a:srgbClr val="1F2328"/>
-                </a:solidFill>
-                <a:latin typeface="Arial"/>
-              </a:rPr>
-              <a:t>within 2 km vs offshore</a:t>
-            </a:r>
-          </a:p>
-        </p:txBody>
-      </p:sp>
-      <p:sp>
-        <p:nvSpPr>
-          <p:cNvPr id="61" name="stat 2 value"/>
-          <p:cNvSpPr txBox="1"/>
-          <p:nvPr/>
-        </p:nvSpPr>
-        <p:spPr>
-          <a:xfrm>
-            <a:off x="24426672" y="28629864"/>
-            <a:ext cx="4483608" cy="822960"/>
-          </a:xfrm>
-          <a:prstGeom prst="rect">
-            <a:avLst/>
-          </a:prstGeom>
-          <a:noFill/>
-        </p:spPr>
-        <p:txBody>
-          <a:bodyPr wrap="square" anchor="t" lIns="0" rIns="0" tIns="0" bIns="0">
-            <a:spAutoFit/>
-          </a:bodyPr>
-          <a:lstStyle/>
-          <a:p>
-            <a:pPr algn="ctr">
-              <a:spcAft>
-                <a:spcPts val="0"/>
-              </a:spcAft>
-            </a:pPr>
-            <a:r>
-              <a:rPr sz="5200" b="1" i="0">
-                <a:solidFill>
-                  <a:srgbClr val="14213D"/>
-                </a:solidFill>
-                <a:latin typeface="Arial"/>
-              </a:rPr>
-              <a:t>≤ 0.021</a:t>
-            </a:r>
-          </a:p>
-        </p:txBody>
-      </p:sp>
-      <p:sp>
-        <p:nvSpPr>
-          <p:cNvPr id="62" name="stat 2 label"/>
-          <p:cNvSpPr txBox="1"/>
-          <p:nvPr/>
-        </p:nvSpPr>
-        <p:spPr>
-          <a:xfrm>
-            <a:off x="24426672" y="29498544"/>
-            <a:ext cx="4483608" cy="777240"/>
-          </a:xfrm>
-          <a:prstGeom prst="rect">
-            <a:avLst/>
-          </a:prstGeom>
-          <a:noFill/>
-        </p:spPr>
-        <p:txBody>
-          <a:bodyPr wrap="square" anchor="t" lIns="0" rIns="0" tIns="0" bIns="0">
-            <a:spAutoFit/>
-          </a:bodyPr>
-          <a:lstStyle/>
-          <a:p>
-            <a:pPr algn="ctr">
-              <a:spcAft>
-                <a:spcPts val="0"/>
-              </a:spcAft>
-            </a:pPr>
-            <a:r>
-              <a:rPr sz="2000" b="0" i="0">
-                <a:solidFill>
-                  <a:srgbClr val="1F2328"/>
-                </a:solidFill>
-                <a:latin typeface="Arial"/>
-              </a:rPr>
-              <a:t>near-shore recall,</a:t>
-            </a:r>
-          </a:p>
-          <a:p>
-            <a:pPr algn="ctr">
-              <a:spcAft>
-                <a:spcPts val="0"/>
-              </a:spcAft>
-            </a:pPr>
-            <a:r>
-              <a:rPr sz="2000" b="0" i="0">
-                <a:solidFill>
-                  <a:srgbClr val="1F2328"/>
-                </a:solidFill>
-                <a:latin typeface="Arial"/>
-              </a:rPr>
-              <a:t>every cell</a:t>
-            </a:r>
-          </a:p>
-        </p:txBody>
-      </p:sp>
-      <p:sp>
-        <p:nvSpPr>
-          <p:cNvPr id="63" name="stat 3 value"/>
-          <p:cNvSpPr txBox="1"/>
-          <p:nvPr/>
-        </p:nvSpPr>
-        <p:spPr>
-          <a:xfrm>
-            <a:off x="28910280" y="28629864"/>
-            <a:ext cx="4483608" cy="822960"/>
-          </a:xfrm>
-          <a:prstGeom prst="rect">
-            <a:avLst/>
-          </a:prstGeom>
-          <a:noFill/>
-        </p:spPr>
-        <p:txBody>
-          <a:bodyPr wrap="square" anchor="t" lIns="0" rIns="0" tIns="0" bIns="0">
-            <a:spAutoFit/>
-          </a:bodyPr>
-          <a:lstStyle/>
-          <a:p>
-            <a:pPr algn="ctr">
-              <a:spcAft>
-                <a:spcPts val="0"/>
-              </a:spcAft>
-            </a:pPr>
-            <a:r>
-              <a:rPr sz="5200" b="1" i="0">
-                <a:solidFill>
-                  <a:srgbClr val="14213D"/>
-                </a:solidFill>
-                <a:latin typeface="Arial"/>
-              </a:rPr>
-              <a:t>0.4% vs 31%</a:t>
-            </a:r>
-          </a:p>
-        </p:txBody>
-      </p:sp>
-      <p:sp>
-        <p:nvSpPr>
-          <p:cNvPr id="64" name="stat 3 label"/>
-          <p:cNvSpPr txBox="1"/>
-          <p:nvPr/>
-        </p:nvSpPr>
-        <p:spPr>
-          <a:xfrm>
-            <a:off x="28910280" y="29498544"/>
-            <a:ext cx="4483608" cy="777240"/>
-          </a:xfrm>
-          <a:prstGeom prst="rect">
-            <a:avLst/>
-          </a:prstGeom>
-          <a:noFill/>
-        </p:spPr>
-        <p:txBody>
-          <a:bodyPr wrap="square" anchor="t" lIns="0" rIns="0" tIns="0" bIns="0">
-            <a:spAutoFit/>
-          </a:bodyPr>
-          <a:lstStyle/>
-          <a:p>
-            <a:pPr algn="ctr">
-              <a:spcAft>
-                <a:spcPts val="0"/>
-              </a:spcAft>
-            </a:pPr>
-            <a:r>
-              <a:rPr sz="2000" b="0" i="0">
-                <a:solidFill>
-                  <a:srgbClr val="1F2328"/>
-                </a:solidFill>
-                <a:latin typeface="Arial"/>
-              </a:rPr>
-              <a:t>vessels within 2 km of shore:</a:t>
-            </a:r>
-          </a:p>
-          <a:p>
-            <a:pPr algn="ctr">
-              <a:spcAft>
-                <a:spcPts val="0"/>
-              </a:spcAft>
-            </a:pPr>
-            <a:r>
-              <a:rPr sz="2000" b="0" i="0">
-                <a:solidFill>
-                  <a:srgbClr val="1F2328"/>
-                </a:solidFill>
-                <a:latin typeface="Arial"/>
-              </a:rPr>
-              <a:t>training vs verified labels</a:t>
-            </a:r>
-          </a:p>
-        </p:txBody>
-      </p:sp>
-      <p:sp>
-        <p:nvSpPr>
-          <p:cNvPr id="65" name="stat note"/>
-          <p:cNvSpPr txBox="1"/>
-          <p:nvPr/>
-        </p:nvSpPr>
-        <p:spPr>
-          <a:xfrm>
-            <a:off x="19943064" y="30412944"/>
-            <a:ext cx="13450824" cy="822960"/>
-          </a:xfrm>
-          <a:prstGeom prst="rect">
-            <a:avLst/>
-          </a:prstGeom>
-          <a:noFill/>
-        </p:spPr>
-        <p:txBody>
-          <a:bodyPr wrap="square" anchor="t" lIns="0" rIns="0" tIns="0" bIns="0">
-            <a:spAutoFit/>
-          </a:bodyPr>
-          <a:lstStyle/>
-          <a:p>
-            <a:pPr algn="l">
-              <a:spcAft>
-                <a:spcPts val="800"/>
-              </a:spcAft>
-            </a:pPr>
-            <a:r>
-              <a:rPr sz="2000" b="0" i="0">
-                <a:solidFill>
-                  <a:srgbClr val="1F2328"/>
-                </a:solidFill>
-                <a:latin typeface="Arial"/>
-              </a:rPr>
-              <a:t>The machine-made training labels place almost no vessels near shore, and the detectors almost never fire there: the best cell puts 34 of its 4,302 predictions within 2 km. Precision stays at 0.639–0.909 in every cell.</a:t>
-            </a:r>
-          </a:p>
-        </p:txBody>
-      </p:sp>
-      <p:sp>
-        <p:nvSpPr>
-          <p:cNvPr id="66" name="heading: Findings"/>
-          <p:cNvSpPr txBox="1"/>
-          <p:nvPr/>
-        </p:nvSpPr>
-        <p:spPr>
-          <a:xfrm>
-            <a:off x="34299144" y="6702552"/>
-            <a:ext cx="8805672" cy="685800"/>
-          </a:xfrm>
-          <a:prstGeom prst="rect">
-            <a:avLst/>
-          </a:prstGeom>
-          <a:noFill/>
-        </p:spPr>
-        <p:txBody>
-          <a:bodyPr wrap="square" anchor="b" lIns="0" rIns="0" tIns="0" bIns="0">
-            <a:spAutoFit/>
-          </a:bodyPr>
-          <a:lstStyle/>
-          <a:p>
-            <a:pPr algn="ctr">
-              <a:spcAft>
-                <a:spcPts val="0"/>
-              </a:spcAft>
-            </a:pPr>
-            <a:r>
               <a:rPr sz="4200" b="1" i="0">
                 <a:solidFill>
                   <a:srgbClr val="14213D"/>
@@ -6375,7 +6350,7 @@
       </p:sp>
       <p:cxnSp>
         <p:nvCxnSpPr>
-          <p:cNvPr id="67" name="rule: Findings"/>
+          <p:cNvPr id="62" name="rule: Findings"/>
           <p:cNvCxnSpPr/>
           <p:nvPr/>
         </p:nvCxnSpPr>
@@ -6410,7 +6385,7 @@
       </p:cxnSp>
       <p:sp>
         <p:nvSpPr>
-          <p:cNvPr id="68" name="hero number"/>
+          <p:cNvPr id="63" name="hero number"/>
           <p:cNvSpPr txBox="1"/>
           <p:nvPr/>
         </p:nvSpPr>
@@ -6449,7 +6424,7 @@
       </p:sp>
       <p:sp>
         <p:nvSpPr>
-          <p:cNvPr id="69" name="hero caption"/>
+          <p:cNvPr id="64" name="hero caption"/>
           <p:cNvSpPr txBox="1"/>
           <p:nvPr/>
         </p:nvSpPr>
@@ -6488,7 +6463,7 @@
       </p:sp>
       <p:sp>
         <p:nvSpPr>
-          <p:cNvPr id="70" name="findings"/>
+          <p:cNvPr id="65" name="findings"/>
           <p:cNvSpPr txBox="1"/>
           <p:nvPr/>
         </p:nvSpPr>
@@ -6631,7 +6606,7 @@
       </p:sp>
       <p:sp>
         <p:nvSpPr>
-          <p:cNvPr id="71" name="heading: Limits"/>
+          <p:cNvPr id="66" name="heading: Limits"/>
           <p:cNvSpPr txBox="1"/>
           <p:nvPr/>
         </p:nvSpPr>
@@ -6670,7 +6645,7 @@
       </p:sp>
       <p:cxnSp>
         <p:nvCxnSpPr>
-          <p:cNvPr id="72" name="rule: Limits"/>
+          <p:cNvPr id="67" name="rule: Limits"/>
           <p:cNvCxnSpPr/>
           <p:nvPr/>
         </p:nvCxnSpPr>
@@ -6705,7 +6680,7 @@
       </p:cxnSp>
       <p:sp>
         <p:nvSpPr>
-          <p:cNvPr id="73" name="limits"/>
+          <p:cNvPr id="68" name="limits"/>
           <p:cNvSpPr txBox="1"/>
           <p:nvPr/>
         </p:nvSpPr>
@@ -6816,7 +6791,7 @@
       </p:sp>
       <p:sp>
         <p:nvSpPr>
-          <p:cNvPr id="74" name="heading: Open questions &amp; next steps"/>
+          <p:cNvPr id="69" name="heading: Open questions &amp; next steps"/>
           <p:cNvSpPr txBox="1"/>
           <p:nvPr/>
         </p:nvSpPr>
@@ -6855,7 +6830,7 @@
       </p:sp>
       <p:cxnSp>
         <p:nvCxnSpPr>
-          <p:cNvPr id="75" name="rule: Open questions &amp; next steps"/>
+          <p:cNvPr id="70" name="rule: Open questions &amp; next steps"/>
           <p:cNvCxnSpPr/>
           <p:nvPr/>
         </p:nvCxnSpPr>
@@ -6890,7 +6865,7 @@
       </p:cxnSp>
       <p:sp>
         <p:nvSpPr>
-          <p:cNvPr id="76" name="open questions"/>
+          <p:cNvPr id="71" name="open questions"/>
           <p:cNvSpPr txBox="1"/>
           <p:nvPr/>
         </p:nvSpPr>

</xml_diff>

<commit_message>
P10.14: rebuild poster.pptx from the synced builder
Replaces the hand-edited PowerPoint (P10.13 folded its edits into
build_pptx.py) with the generated one: same text as the owner's version
except the renamed column-3 heading, and every text run sets Arial, its
size and its color explicitly. check_poster.py passes (19 numbers match)
and the pptx validator passes.
</commit_message>
<xml_diff>
--- a/docs/poster/poster.pptx
+++ b/docs/poster/poster.pptx
@@ -5665,7 +5665,7 @@
         <p:spPr>
           <a:xfrm>
             <a:off x="19687032" y="6702552"/>
-            <a:ext cx="13962888" cy="685800"/>
+            <a:ext cx="12243816" cy="685800"/>
           </a:xfrm>
           <a:prstGeom prst="rect">
             <a:avLst/>
@@ -5704,7 +5704,7 @@
         <p:spPr>
           <a:xfrm>
             <a:off x="19687032" y="7479792"/>
-            <a:ext cx="13962888" cy="0"/>
+            <a:ext cx="12243816" cy="0"/>
           </a:xfrm>
           <a:prstGeom prst="line">
             <a:avLst/>
@@ -5747,7 +5747,7 @@
         <p:spPr>
           <a:xfrm>
             <a:off x="20034504" y="7754112"/>
-            <a:ext cx="13267944" cy="9211221"/>
+            <a:ext cx="11548872" cy="8698722"/>
           </a:xfrm>
           <a:prstGeom prst="rect">
             <a:avLst/>
@@ -5762,8 +5762,8 @@
         </p:nvSpPr>
         <p:spPr>
           <a:xfrm>
-            <a:off x="19943064" y="17102493"/>
-            <a:ext cx="13450824" cy="914400"/>
+            <a:off x="19943064" y="16589994"/>
+            <a:ext cx="11731752" cy="914400"/>
           </a:xfrm>
           <a:prstGeom prst="rect">
             <a:avLst/>
@@ -5795,14 +5795,14 @@
       </p:sp>
       <p:sp>
         <p:nvSpPr>
-          <p:cNvPr id="53" name="heading: SAR vs. optical depends on backbone and budget"/>
+          <p:cNvPr id="53" name="heading: SAR vs. optical: no stable winner"/>
           <p:cNvSpPr txBox="1"/>
           <p:nvPr/>
         </p:nvSpPr>
         <p:spPr>
           <a:xfrm>
-            <a:off x="19687032" y="18717768"/>
-            <a:ext cx="13962888" cy="685800"/>
+            <a:off x="19687032" y="18242280"/>
+            <a:ext cx="12243816" cy="685800"/>
           </a:xfrm>
           <a:prstGeom prst="rect">
             <a:avLst/>
@@ -5827,21 +5827,21 @@
                 </a:solidFill>
                 <a:latin typeface="Arial"/>
               </a:rPr>
-              <a:t>SAR vs. optical depends on backbone and budget</a:t>
+              <a:t>SAR vs. optical: no stable winner</a:t>
             </a:r>
           </a:p>
         </p:txBody>
       </p:sp>
       <p:cxnSp>
         <p:nvCxnSpPr>
-          <p:cNvPr id="54" name="rule: SAR vs. optical depends on backbone and budget"/>
+          <p:cNvPr id="54" name="rule: SAR vs. optical: no stable winner"/>
           <p:cNvCxnSpPr/>
           <p:nvPr/>
         </p:nvCxnSpPr>
         <p:spPr>
           <a:xfrm>
-            <a:off x="19687032" y="19495008"/>
-            <a:ext cx="13962888" cy="0"/>
+            <a:off x="19687032" y="19019520"/>
+            <a:ext cx="12243816" cy="0"/>
           </a:xfrm>
           <a:prstGeom prst="line">
             <a:avLst/>
@@ -5883,8 +5883,8 @@
         </p:blipFill>
         <p:spPr>
           <a:xfrm>
-            <a:off x="20034504" y="19769328"/>
-            <a:ext cx="13267944" cy="5539106"/>
+            <a:off x="20034504" y="19293840"/>
+            <a:ext cx="11548872" cy="5374421"/>
           </a:xfrm>
           <a:prstGeom prst="rect">
             <a:avLst/>
@@ -5899,8 +5899,8 @@
         </p:nvSpPr>
         <p:spPr>
           <a:xfrm>
-            <a:off x="19943064" y="25445594"/>
-            <a:ext cx="13450824" cy="1463040"/>
+            <a:off x="19943064" y="24805421"/>
+            <a:ext cx="11731752" cy="1463040"/>
           </a:xfrm>
           <a:prstGeom prst="rect">
             <a:avLst/>
@@ -5947,8 +5947,8 @@
         </p:nvSpPr>
         <p:spPr>
           <a:xfrm>
-            <a:off x="19687032" y="27038808"/>
-            <a:ext cx="13962888" cy="685800"/>
+            <a:off x="19687032" y="27221688"/>
+            <a:ext cx="12243816" cy="685800"/>
           </a:xfrm>
           <a:prstGeom prst="rect">
             <a:avLst/>
@@ -5986,8 +5986,8 @@
         </p:nvCxnSpPr>
         <p:spPr>
           <a:xfrm>
-            <a:off x="19687032" y="27816048"/>
-            <a:ext cx="13962888" cy="0"/>
+            <a:off x="19687032" y="27998928"/>
+            <a:ext cx="12243816" cy="0"/>
           </a:xfrm>
           <a:prstGeom prst="line">
             <a:avLst/>
@@ -6021,8 +6021,8 @@
         </p:nvSpPr>
         <p:spPr>
           <a:xfrm>
-            <a:off x="19943064" y="28090368"/>
-            <a:ext cx="6588251" cy="3547871"/>
+            <a:off x="19943064" y="28273248"/>
+            <a:ext cx="5728716" cy="3364991"/>
           </a:xfrm>
           <a:prstGeom prst="rect">
             <a:avLst/>
@@ -6169,8 +6169,8 @@
         </p:nvSpPr>
         <p:spPr>
           <a:xfrm>
-            <a:off x="26805636" y="28090368"/>
-            <a:ext cx="6588251" cy="3547871"/>
+            <a:off x="25946100" y="28273248"/>
+            <a:ext cx="5728716" cy="3364991"/>
           </a:xfrm>
           <a:prstGeom prst="rect">
             <a:avLst/>
@@ -6317,8 +6317,8 @@
         </p:nvSpPr>
         <p:spPr>
           <a:xfrm>
-            <a:off x="34299144" y="6702552"/>
-            <a:ext cx="8805672" cy="685800"/>
+            <a:off x="32580072" y="6702552"/>
+            <a:ext cx="10524744" cy="685800"/>
           </a:xfrm>
           <a:prstGeom prst="rect">
             <a:avLst/>
@@ -6356,8 +6356,8 @@
         </p:nvCxnSpPr>
         <p:spPr>
           <a:xfrm>
-            <a:off x="34299144" y="7479792"/>
-            <a:ext cx="8805672" cy="0"/>
+            <a:off x="32580072" y="7479792"/>
+            <a:ext cx="10524744" cy="0"/>
           </a:xfrm>
           <a:prstGeom prst="line">
             <a:avLst/>
@@ -6385,14 +6385,14 @@
       </p:cxnSp>
       <p:sp>
         <p:nvSpPr>
-          <p:cNvPr id="63" name="hero number"/>
+          <p:cNvPr id="63" name="findings"/>
           <p:cNvSpPr txBox="1"/>
           <p:nvPr/>
         </p:nvSpPr>
         <p:spPr>
           <a:xfrm>
-            <a:off x="34555176" y="7662672"/>
-            <a:ext cx="8293608" cy="1005840"/>
+            <a:off x="32836104" y="7754112"/>
+            <a:ext cx="10012680" cy="9345167"/>
           </a:xfrm>
           <a:prstGeom prst="rect">
             <a:avLst/>
@@ -6405,87 +6405,9 @@
           </a:bodyPr>
           <a:lstStyle/>
           <a:p>
-            <a:pPr algn="ctr">
-              <a:spcAft>
-                <a:spcPts val="0"/>
-              </a:spcAft>
-            </a:pPr>
-            <a:r>
-              <a:rPr sz="6000" b="1" i="0">
-                <a:solidFill>
-                  <a:srgbClr val="009E73"/>
-                </a:solidFill>
-                <a:latin typeface="Arial"/>
-              </a:rPr>
-              <a:t>12 / 12</a:t>
-            </a:r>
-          </a:p>
-        </p:txBody>
-      </p:sp>
-      <p:sp>
-        <p:nvSpPr>
-          <p:cNvPr id="64" name="hero caption"/>
-          <p:cNvSpPr txBox="1"/>
-          <p:nvPr/>
-        </p:nvSpPr>
-        <p:spPr>
-          <a:xfrm>
-            <a:off x="34555176" y="8714232"/>
-            <a:ext cx="8293608" cy="1005840"/>
-          </a:xfrm>
-          <a:prstGeom prst="rect">
-            <a:avLst/>
-          </a:prstGeom>
-          <a:noFill/>
-        </p:spPr>
-        <p:txBody>
-          <a:bodyPr wrap="square" anchor="t" lIns="0" rIns="0" tIns="0" bIns="0">
-            <a:spAutoFit/>
-          </a:bodyPr>
-          <a:lstStyle/>
-          <a:p>
-            <a:pPr algn="ctr">
-              <a:spcAft>
-                <a:spcPts val="800"/>
-              </a:spcAft>
-            </a:pPr>
-            <a:r>
-              <a:rPr sz="2900" b="0" i="0">
-                <a:solidFill>
-                  <a:srgbClr val="1F2328"/>
-                </a:solidFill>
-                <a:latin typeface="Arial"/>
-              </a:rPr>
-              <a:t>pretrained-vs-random comparisons at 12 training scenes have a 95% interval above zero.</a:t>
-            </a:r>
-          </a:p>
-        </p:txBody>
-      </p:sp>
-      <p:sp>
-        <p:nvSpPr>
-          <p:cNvPr id="65" name="findings"/>
-          <p:cNvSpPr txBox="1"/>
-          <p:nvPr/>
-        </p:nvSpPr>
-        <p:spPr>
-          <a:xfrm>
-            <a:off x="34555176" y="9994392"/>
-            <a:ext cx="8293608" cy="9025128"/>
-          </a:xfrm>
-          <a:prstGeom prst="rect">
-            <a:avLst/>
-          </a:prstGeom>
-          <a:noFill/>
-        </p:spPr>
-        <p:txBody>
-          <a:bodyPr wrap="square" anchor="t" lIns="0" rIns="0" tIns="0" bIns="0">
-            <a:spAutoFit/>
-          </a:bodyPr>
-          <a:lstStyle/>
-          <a:p>
             <a:pPr algn="l" marL="411480" indent="-411480">
               <a:spcAft>
-                <a:spcPts val="1200"/>
+                <a:spcPts val="1000"/>
               </a:spcAft>
               <a:buClr>
                 <a:srgbClr val="14213D"/>
@@ -6515,7 +6437,7 @@
           <a:p>
             <a:pPr algn="l" marL="411480" indent="-411480">
               <a:spcAft>
-                <a:spcPts val="1200"/>
+                <a:spcPts val="1000"/>
               </a:spcAft>
               <a:buClr>
                 <a:srgbClr val="14213D"/>
@@ -6545,7 +6467,7 @@
           <a:p>
             <a:pPr algn="l" marL="411480" indent="-411480">
               <a:spcAft>
-                <a:spcPts val="1200"/>
+                <a:spcPts val="1000"/>
               </a:spcAft>
               <a:buClr>
                 <a:srgbClr val="14213D"/>
@@ -6570,6 +6492,36 @@
                 <a:latin typeface="Arial"/>
               </a:rPr>
               <a:t> With a seeded 3-channel stem instead of band slicing, BigEarthNet-S2 beats random at every budget (+0.025 to +0.063 test F1).</a:t>
+            </a:r>
+          </a:p>
+          <a:p>
+            <a:pPr algn="l" marL="411480" indent="-411480">
+              <a:spcAft>
+                <a:spcPts val="1000"/>
+              </a:spcAft>
+              <a:buClr>
+                <a:srgbClr val="14213D"/>
+              </a:buClr>
+              <a:buFont typeface="Arial"/>
+              <a:buAutoNum type="arabicPlain"/>
+            </a:pPr>
+            <a:r>
+              <a:rPr sz="2900" b="1" i="0">
+                <a:solidFill>
+                  <a:srgbClr val="1F2328"/>
+                </a:solidFill>
+                <a:latin typeface="Arial"/>
+              </a:rPr>
+              <a:t>No detector works near shore:</a:t>
+            </a:r>
+            <a:r>
+              <a:rPr sz="2900" b="0" i="0">
+                <a:solidFill>
+                  <a:srgbClr val="1F2328"/>
+                </a:solidFill>
+                <a:latin typeface="Arial"/>
+              </a:rPr>
+              <a:t> recall ≤ 0.021 within 2 km in every cell. Training labels put 0.4% of vessels there; the verified set, 31%.</a:t>
             </a:r>
           </a:p>
           <a:p>
@@ -6590,7 +6542,7 @@
                 </a:solidFill>
                 <a:latin typeface="Arial"/>
               </a:rPr>
-              <a:t>No detector works near shore:</a:t>
+              <a:t>ImageNet is the strongest default.</a:t>
             </a:r>
             <a:r>
               <a:rPr sz="2900" b="0" i="0">
@@ -6599,21 +6551,21 @@
                 </a:solidFill>
                 <a:latin typeface="Arial"/>
               </a:rPr>
-              <a:t> recall ≤ 0.021 within 2 km in every cell. Training labels put 0.4% of vessels there; the verified set, 31%.</a:t>
-            </a:r>
-          </a:p>
-        </p:txBody>
-      </p:sp>
-      <p:sp>
-        <p:nvSpPr>
-          <p:cNvPr id="66" name="heading: Limits"/>
+              <a:t> ImageNet beats SAR pretraining in 7 of 16 comparisons (SAR wins 3). The best cell on both test (0.888) and verified F1 (0.574) is the ImageNet ConvNeXt with 111 scenes.</a:t>
+            </a:r>
+          </a:p>
+        </p:txBody>
+      </p:sp>
+      <p:sp>
+        <p:nvSpPr>
+          <p:cNvPr id="64" name="heading: Limits"/>
           <p:cNvSpPr txBox="1"/>
           <p:nvPr/>
         </p:nvSpPr>
         <p:spPr>
           <a:xfrm>
-            <a:off x="34299144" y="19056096"/>
-            <a:ext cx="8805672" cy="685800"/>
+            <a:off x="32580072" y="17172432"/>
+            <a:ext cx="10524744" cy="685800"/>
           </a:xfrm>
           <a:prstGeom prst="rect">
             <a:avLst/>
@@ -6645,14 +6597,14 @@
       </p:sp>
       <p:cxnSp>
         <p:nvCxnSpPr>
-          <p:cNvPr id="67" name="rule: Limits"/>
+          <p:cNvPr id="65" name="rule: Limits"/>
           <p:cNvCxnSpPr/>
           <p:nvPr/>
         </p:nvCxnSpPr>
         <p:spPr>
           <a:xfrm>
-            <a:off x="34299144" y="19833336"/>
-            <a:ext cx="8805672" cy="0"/>
+            <a:off x="32580072" y="17949672"/>
+            <a:ext cx="10524744" cy="0"/>
           </a:xfrm>
           <a:prstGeom prst="line">
             <a:avLst/>
@@ -6680,14 +6632,14 @@
       </p:cxnSp>
       <p:sp>
         <p:nvSpPr>
-          <p:cNvPr id="68" name="limits"/>
+          <p:cNvPr id="66" name="limits"/>
           <p:cNvSpPr txBox="1"/>
           <p:nvPr/>
         </p:nvSpPr>
         <p:spPr>
           <a:xfrm>
-            <a:off x="34555176" y="20107656"/>
-            <a:ext cx="8293608" cy="6044183"/>
+            <a:off x="32836104" y="18223992"/>
+            <a:ext cx="10012680" cy="6556247"/>
           </a:xfrm>
           <a:prstGeom prst="rect">
             <a:avLst/>
@@ -6787,103 +6739,6 @@
               <a:t>Checkpoints differ in objective and corpus, not only domain.</a:t>
             </a:r>
           </a:p>
-        </p:txBody>
-      </p:sp>
-      <p:sp>
-        <p:nvSpPr>
-          <p:cNvPr id="69" name="heading: Open questions &amp; next steps"/>
-          <p:cNvSpPr txBox="1"/>
-          <p:nvPr/>
-        </p:nvSpPr>
-        <p:spPr>
-          <a:xfrm>
-            <a:off x="34299144" y="26289000"/>
-            <a:ext cx="8805672" cy="685800"/>
-          </a:xfrm>
-          <a:prstGeom prst="rect">
-            <a:avLst/>
-          </a:prstGeom>
-          <a:noFill/>
-        </p:spPr>
-        <p:txBody>
-          <a:bodyPr wrap="square" anchor="b" lIns="0" rIns="0" tIns="0" bIns="0">
-            <a:spAutoFit/>
-          </a:bodyPr>
-          <a:lstStyle/>
-          <a:p>
-            <a:pPr algn="ctr">
-              <a:spcAft>
-                <a:spcPts val="0"/>
-              </a:spcAft>
-            </a:pPr>
-            <a:r>
-              <a:rPr sz="4200" b="1" i="0">
-                <a:solidFill>
-                  <a:srgbClr val="14213D"/>
-                </a:solidFill>
-                <a:latin typeface="Arial"/>
-              </a:rPr>
-              <a:t>Open questions &amp; next steps</a:t>
-            </a:r>
-          </a:p>
-        </p:txBody>
-      </p:sp>
-      <p:cxnSp>
-        <p:nvCxnSpPr>
-          <p:cNvPr id="70" name="rule: Open questions &amp; next steps"/>
-          <p:cNvCxnSpPr/>
-          <p:nvPr/>
-        </p:nvCxnSpPr>
-        <p:spPr>
-          <a:xfrm>
-            <a:off x="34299144" y="27066240"/>
-            <a:ext cx="8805672" cy="0"/>
-          </a:xfrm>
-          <a:prstGeom prst="line">
-            <a:avLst/>
-          </a:prstGeom>
-          <a:ln w="57150">
-            <a:solidFill>
-              <a:srgbClr val="B8BEC8"/>
-            </a:solidFill>
-          </a:ln>
-        </p:spPr>
-        <p:style>
-          <a:lnRef idx="2">
-            <a:schemeClr val="accent1"/>
-          </a:lnRef>
-          <a:fillRef idx="0">
-            <a:schemeClr val="accent1"/>
-          </a:fillRef>
-          <a:effectRef idx="1">
-            <a:schemeClr val="accent1"/>
-          </a:effectRef>
-          <a:fontRef idx="minor">
-            <a:schemeClr val="tx1"/>
-          </a:fontRef>
-        </p:style>
-      </p:cxnSp>
-      <p:sp>
-        <p:nvSpPr>
-          <p:cNvPr id="71" name="open questions"/>
-          <p:cNvSpPr txBox="1"/>
-          <p:nvPr/>
-        </p:nvSpPr>
-        <p:spPr>
-          <a:xfrm>
-            <a:off x="34555176" y="27340560"/>
-            <a:ext cx="8293608" cy="4297679"/>
-          </a:xfrm>
-          <a:prstGeom prst="rect">
-            <a:avLst/>
-          </a:prstGeom>
-          <a:noFill/>
-        </p:spPr>
-        <p:txBody>
-          <a:bodyPr wrap="square" anchor="t" lIns="0" rIns="0" tIns="0" bIns="0">
-            <a:spAutoFit/>
-          </a:bodyPr>
-          <a:lstStyle/>
           <a:p>
             <a:pPr algn="l" marL="347472" indent="-347472">
               <a:spcAft>
@@ -6903,7 +6758,148 @@
                 </a:solidFill>
                 <a:latin typeface="Arial"/>
               </a:rPr>
+              <a:t>In-region test: Sentinel-1 revisits put some test scenes near training scenes, so test F1 measures in-region generalization, not generalization to new regions.</a:t>
+            </a:r>
+          </a:p>
+        </p:txBody>
+      </p:sp>
+      <p:sp>
+        <p:nvSpPr>
+          <p:cNvPr id="67" name="heading: Open questions &amp; next steps"/>
+          <p:cNvSpPr txBox="1"/>
+          <p:nvPr/>
+        </p:nvSpPr>
+        <p:spPr>
+          <a:xfrm>
+            <a:off x="32580072" y="24862536"/>
+            <a:ext cx="10524744" cy="685800"/>
+          </a:xfrm>
+          <a:prstGeom prst="rect">
+            <a:avLst/>
+          </a:prstGeom>
+          <a:noFill/>
+        </p:spPr>
+        <p:txBody>
+          <a:bodyPr wrap="square" anchor="b" lIns="0" rIns="0" tIns="0" bIns="0">
+            <a:spAutoFit/>
+          </a:bodyPr>
+          <a:lstStyle/>
+          <a:p>
+            <a:pPr algn="ctr">
+              <a:spcAft>
+                <a:spcPts val="0"/>
+              </a:spcAft>
+            </a:pPr>
+            <a:r>
+              <a:rPr sz="4200" b="1" i="0">
+                <a:solidFill>
+                  <a:srgbClr val="14213D"/>
+                </a:solidFill>
+                <a:latin typeface="Arial"/>
+              </a:rPr>
+              <a:t>Open questions &amp; next steps</a:t>
+            </a:r>
+          </a:p>
+        </p:txBody>
+      </p:sp>
+      <p:cxnSp>
+        <p:nvCxnSpPr>
+          <p:cNvPr id="68" name="rule: Open questions &amp; next steps"/>
+          <p:cNvCxnSpPr/>
+          <p:nvPr/>
+        </p:nvCxnSpPr>
+        <p:spPr>
+          <a:xfrm>
+            <a:off x="32580072" y="25639776"/>
+            <a:ext cx="10524744" cy="0"/>
+          </a:xfrm>
+          <a:prstGeom prst="line">
+            <a:avLst/>
+          </a:prstGeom>
+          <a:ln w="57150">
+            <a:solidFill>
+              <a:srgbClr val="B8BEC8"/>
+            </a:solidFill>
+          </a:ln>
+        </p:spPr>
+        <p:style>
+          <a:lnRef idx="2">
+            <a:schemeClr val="accent1"/>
+          </a:lnRef>
+          <a:fillRef idx="0">
+            <a:schemeClr val="accent1"/>
+          </a:fillRef>
+          <a:effectRef idx="1">
+            <a:schemeClr val="accent1"/>
+          </a:effectRef>
+          <a:fontRef idx="minor">
+            <a:schemeClr val="tx1"/>
+          </a:fontRef>
+        </p:style>
+      </p:cxnSp>
+      <p:sp>
+        <p:nvSpPr>
+          <p:cNvPr id="69" name="open questions"/>
+          <p:cNvSpPr txBox="1"/>
+          <p:nvPr/>
+        </p:nvSpPr>
+        <p:spPr>
+          <a:xfrm>
+            <a:off x="32836104" y="25914096"/>
+            <a:ext cx="10012680" cy="5724143"/>
+          </a:xfrm>
+          <a:prstGeom prst="rect">
+            <a:avLst/>
+          </a:prstGeom>
+          <a:noFill/>
+        </p:spPr>
+        <p:txBody>
+          <a:bodyPr wrap="square" anchor="t" lIns="0" rIns="0" tIns="0" bIns="0">
+            <a:spAutoFit/>
+          </a:bodyPr>
+          <a:lstStyle/>
+          <a:p>
+            <a:pPr algn="l" marL="347472" indent="-347472">
+              <a:spcAft>
+                <a:spcPts val="800"/>
+              </a:spcAft>
+              <a:buSzPct val="70000"/>
+              <a:buClr>
+                <a:srgbClr val="14213D"/>
+              </a:buClr>
+              <a:buFont typeface="Arial"/>
+              <a:buChar char="■"/>
+            </a:pPr>
+            <a:r>
+              <a:rPr sz="2900" b="0" i="0">
+                <a:solidFill>
+                  <a:srgbClr val="1F2328"/>
+                </a:solidFill>
+                <a:latin typeface="Arial"/>
+              </a:rPr>
               <a:t>How do geospatial foundation models pretrained jointly on SAR and optical imagery fare against these single-source checkpoints?</a:t>
+            </a:r>
+          </a:p>
+          <a:p>
+            <a:pPr algn="l" marL="347472" indent="-347472">
+              <a:spcAft>
+                <a:spcPts val="800"/>
+              </a:spcAft>
+              <a:buSzPct val="70000"/>
+              <a:buClr>
+                <a:srgbClr val="14213D"/>
+              </a:buClr>
+              <a:buFont typeface="Arial"/>
+              <a:buChar char="■"/>
+            </a:pPr>
+            <a:r>
+              <a:rPr sz="2900" b="0" i="0">
+                <a:solidFill>
+                  <a:srgbClr val="1F2328"/>
+                </a:solidFill>
+                <a:latin typeface="Arial"/>
+              </a:rPr>
+              <a:t>Does SAR pretraining still trail ImageNet when both use the same objective, architecture and number of pretraining images?</a:t>
             </a:r>
           </a:p>
           <a:p>

</xml_diff>